<commit_message>
brand: integrate official NxtWave vector logos across presentation, landing page, admin portal, and assets
</commit_message>
<xml_diff>
--- a/campus_relay_asset/Campus_Relay_Growth_Plan.pptx
+++ b/campus_relay_asset/Campus_Relay_Growth_Plan.pptx
@@ -3178,8 +3178,8 @@
         </p:nvSpPr>
         <p:spPr>
           <a:xfrm>
-            <a:off x="10515600" y="457200"/>
-            <a:ext cx="914400" cy="320040"/>
+            <a:off x="9509760" y="457200"/>
+            <a:ext cx="1005840" cy="320040"/>
           </a:xfrm>
           <a:prstGeom prst="rect">
             <a:avLst/>
@@ -3205,9 +3205,33 @@
           </a:p>
         </p:txBody>
       </p:sp>
-      <p:sp>
-        <p:nvSpPr>
-          <p:cNvPr id="5" name="Rounded Rectangle 4"/>
+      <p:pic>
+        <p:nvPicPr>
+          <p:cNvPr id="5" name="Picture 4" descr="nxtwave_white_logo.png"/>
+          <p:cNvPicPr>
+            <a:picLocks noChangeAspect="1"/>
+          </p:cNvPicPr>
+          <p:nvPr/>
+        </p:nvPicPr>
+        <p:blipFill>
+          <a:blip r:embed="rId2"/>
+          <a:stretch>
+            <a:fillRect/>
+          </a:stretch>
+        </p:blipFill>
+        <p:spPr>
+          <a:xfrm>
+            <a:off x="10744200" y="384048"/>
+            <a:ext cx="749808" cy="422969"/>
+          </a:xfrm>
+          <a:prstGeom prst="rect">
+            <a:avLst/>
+          </a:prstGeom>
+        </p:spPr>
+      </p:pic>
+      <p:sp>
+        <p:nvSpPr>
+          <p:cNvPr id="6" name="Rounded Rectangle 5"/>
           <p:cNvSpPr/>
           <p:nvPr/>
         </p:nvSpPr>
@@ -3252,7 +3276,7 @@
       </p:sp>
       <p:sp>
         <p:nvSpPr>
-          <p:cNvPr id="6" name="TextBox 5"/>
+          <p:cNvPr id="7" name="TextBox 6"/>
           <p:cNvSpPr txBox="1"/>
           <p:nvPr/>
         </p:nvSpPr>
@@ -3311,7 +3335,7 @@
       </p:sp>
       <p:sp>
         <p:nvSpPr>
-          <p:cNvPr id="7" name="Rounded Rectangle 6"/>
+          <p:cNvPr id="8" name="Rounded Rectangle 7"/>
           <p:cNvSpPr/>
           <p:nvPr/>
         </p:nvSpPr>
@@ -3356,7 +3380,7 @@
       </p:sp>
       <p:sp>
         <p:nvSpPr>
-          <p:cNvPr id="8" name="TextBox 7"/>
+          <p:cNvPr id="9" name="TextBox 8"/>
           <p:cNvSpPr txBox="1"/>
           <p:nvPr/>
         </p:nvSpPr>
@@ -3415,7 +3439,7 @@
       </p:sp>
       <p:sp>
         <p:nvSpPr>
-          <p:cNvPr id="9" name="Rounded Rectangle 8"/>
+          <p:cNvPr id="10" name="Rounded Rectangle 9"/>
           <p:cNvSpPr/>
           <p:nvPr/>
         </p:nvSpPr>
@@ -3460,7 +3484,7 @@
       </p:sp>
       <p:sp>
         <p:nvSpPr>
-          <p:cNvPr id="10" name="TextBox 9"/>
+          <p:cNvPr id="11" name="TextBox 10"/>
           <p:cNvSpPr txBox="1"/>
           <p:nvPr/>
         </p:nvSpPr>
@@ -3519,7 +3543,7 @@
       </p:sp>
       <p:sp>
         <p:nvSpPr>
-          <p:cNvPr id="11" name="Rounded Rectangle 10"/>
+          <p:cNvPr id="12" name="Rounded Rectangle 11"/>
           <p:cNvSpPr/>
           <p:nvPr/>
         </p:nvSpPr>
@@ -3564,7 +3588,7 @@
       </p:sp>
       <p:sp>
         <p:nvSpPr>
-          <p:cNvPr id="12" name="TextBox 11"/>
+          <p:cNvPr id="13" name="TextBox 12"/>
           <p:cNvSpPr txBox="1"/>
           <p:nvPr/>
         </p:nvSpPr>
@@ -3623,7 +3647,7 @@
       </p:sp>
       <p:sp>
         <p:nvSpPr>
-          <p:cNvPr id="13" name="Rounded Rectangle 12"/>
+          <p:cNvPr id="14" name="Rounded Rectangle 13"/>
           <p:cNvSpPr/>
           <p:nvPr/>
         </p:nvSpPr>
@@ -3668,7 +3692,7 @@
       </p:sp>
       <p:sp>
         <p:nvSpPr>
-          <p:cNvPr id="14" name="TextBox 13"/>
+          <p:cNvPr id="15" name="TextBox 14"/>
           <p:cNvSpPr txBox="1"/>
           <p:nvPr/>
         </p:nvSpPr>
@@ -3811,7 +3835,7 @@
       </p:sp>
       <p:sp>
         <p:nvSpPr>
-          <p:cNvPr id="15" name="Rounded Rectangle 14"/>
+          <p:cNvPr id="16" name="Rounded Rectangle 15"/>
           <p:cNvSpPr/>
           <p:nvPr/>
         </p:nvSpPr>
@@ -3856,7 +3880,7 @@
       </p:sp>
       <p:sp>
         <p:nvSpPr>
-          <p:cNvPr id="16" name="TextBox 15"/>
+          <p:cNvPr id="17" name="TextBox 16"/>
           <p:cNvSpPr txBox="1"/>
           <p:nvPr/>
         </p:nvSpPr>
@@ -4101,8 +4125,8 @@
         </p:nvSpPr>
         <p:spPr>
           <a:xfrm>
-            <a:off x="10515600" y="457200"/>
-            <a:ext cx="914400" cy="320040"/>
+            <a:off x="9509760" y="457200"/>
+            <a:ext cx="1005840" cy="320040"/>
           </a:xfrm>
           <a:prstGeom prst="rect">
             <a:avLst/>
@@ -4128,9 +4152,33 @@
           </a:p>
         </p:txBody>
       </p:sp>
-      <p:sp>
-        <p:nvSpPr>
-          <p:cNvPr id="5" name="Rounded Rectangle 4"/>
+      <p:pic>
+        <p:nvPicPr>
+          <p:cNvPr id="5" name="Picture 4" descr="nxtwave_white_logo.png"/>
+          <p:cNvPicPr>
+            <a:picLocks noChangeAspect="1"/>
+          </p:cNvPicPr>
+          <p:nvPr/>
+        </p:nvPicPr>
+        <p:blipFill>
+          <a:blip r:embed="rId2"/>
+          <a:stretch>
+            <a:fillRect/>
+          </a:stretch>
+        </p:blipFill>
+        <p:spPr>
+          <a:xfrm>
+            <a:off x="10744200" y="384048"/>
+            <a:ext cx="749808" cy="422969"/>
+          </a:xfrm>
+          <a:prstGeom prst="rect">
+            <a:avLst/>
+          </a:prstGeom>
+        </p:spPr>
+      </p:pic>
+      <p:sp>
+        <p:nvSpPr>
+          <p:cNvPr id="6" name="Rounded Rectangle 5"/>
           <p:cNvSpPr/>
           <p:nvPr/>
         </p:nvSpPr>
@@ -4175,7 +4223,7 @@
       </p:sp>
       <p:sp>
         <p:nvSpPr>
-          <p:cNvPr id="6" name="TextBox 5"/>
+          <p:cNvPr id="7" name="TextBox 6"/>
           <p:cNvSpPr txBox="1"/>
           <p:nvPr/>
         </p:nvSpPr>
@@ -4318,7 +4366,7 @@
       </p:sp>
       <p:sp>
         <p:nvSpPr>
-          <p:cNvPr id="7" name="Rounded Rectangle 6"/>
+          <p:cNvPr id="8" name="Rounded Rectangle 7"/>
           <p:cNvSpPr/>
           <p:nvPr/>
         </p:nvSpPr>
@@ -4363,7 +4411,7 @@
       </p:sp>
       <p:sp>
         <p:nvSpPr>
-          <p:cNvPr id="8" name="TextBox 7"/>
+          <p:cNvPr id="9" name="TextBox 8"/>
           <p:cNvSpPr txBox="1"/>
           <p:nvPr/>
         </p:nvSpPr>
@@ -4635,8 +4683,8 @@
         </p:nvSpPr>
         <p:spPr>
           <a:xfrm>
-            <a:off x="10515600" y="457200"/>
-            <a:ext cx="914400" cy="320040"/>
+            <a:off x="9509760" y="457200"/>
+            <a:ext cx="1005840" cy="320040"/>
           </a:xfrm>
           <a:prstGeom prst="rect">
             <a:avLst/>
@@ -4662,9 +4710,33 @@
           </a:p>
         </p:txBody>
       </p:sp>
-      <p:sp>
-        <p:nvSpPr>
-          <p:cNvPr id="5" name="Rounded Rectangle 4"/>
+      <p:pic>
+        <p:nvPicPr>
+          <p:cNvPr id="5" name="Picture 4" descr="nxtwave_white_logo.png"/>
+          <p:cNvPicPr>
+            <a:picLocks noChangeAspect="1"/>
+          </p:cNvPicPr>
+          <p:nvPr/>
+        </p:nvPicPr>
+        <p:blipFill>
+          <a:blip r:embed="rId2"/>
+          <a:stretch>
+            <a:fillRect/>
+          </a:stretch>
+        </p:blipFill>
+        <p:spPr>
+          <a:xfrm>
+            <a:off x="10744200" y="384048"/>
+            <a:ext cx="749808" cy="422969"/>
+          </a:xfrm>
+          <a:prstGeom prst="rect">
+            <a:avLst/>
+          </a:prstGeom>
+        </p:spPr>
+      </p:pic>
+      <p:sp>
+        <p:nvSpPr>
+          <p:cNvPr id="6" name="Rounded Rectangle 5"/>
           <p:cNvSpPr/>
           <p:nvPr/>
         </p:nvSpPr>
@@ -4709,7 +4781,7 @@
       </p:sp>
       <p:sp>
         <p:nvSpPr>
-          <p:cNvPr id="6" name="TextBox 5"/>
+          <p:cNvPr id="7" name="TextBox 6"/>
           <p:cNvSpPr txBox="1"/>
           <p:nvPr/>
         </p:nvSpPr>
@@ -4852,7 +4924,7 @@
       </p:sp>
       <p:sp>
         <p:nvSpPr>
-          <p:cNvPr id="7" name="Rounded Rectangle 6"/>
+          <p:cNvPr id="8" name="Rounded Rectangle 7"/>
           <p:cNvSpPr/>
           <p:nvPr/>
         </p:nvSpPr>
@@ -4897,7 +4969,7 @@
       </p:sp>
       <p:sp>
         <p:nvSpPr>
-          <p:cNvPr id="8" name="TextBox 7"/>
+          <p:cNvPr id="9" name="TextBox 8"/>
           <p:cNvSpPr txBox="1"/>
           <p:nvPr/>
         </p:nvSpPr>
@@ -5169,8 +5241,8 @@
         </p:nvSpPr>
         <p:spPr>
           <a:xfrm>
-            <a:off x="10515600" y="457200"/>
-            <a:ext cx="914400" cy="320040"/>
+            <a:off x="9509760" y="457200"/>
+            <a:ext cx="1005840" cy="320040"/>
           </a:xfrm>
           <a:prstGeom prst="rect">
             <a:avLst/>
@@ -5196,9 +5268,33 @@
           </a:p>
         </p:txBody>
       </p:sp>
-      <p:sp>
-        <p:nvSpPr>
-          <p:cNvPr id="5" name="Rounded Rectangle 4"/>
+      <p:pic>
+        <p:nvPicPr>
+          <p:cNvPr id="5" name="Picture 4" descr="nxtwave_white_logo.png"/>
+          <p:cNvPicPr>
+            <a:picLocks noChangeAspect="1"/>
+          </p:cNvPicPr>
+          <p:nvPr/>
+        </p:nvPicPr>
+        <p:blipFill>
+          <a:blip r:embed="rId2"/>
+          <a:stretch>
+            <a:fillRect/>
+          </a:stretch>
+        </p:blipFill>
+        <p:spPr>
+          <a:xfrm>
+            <a:off x="10744200" y="384048"/>
+            <a:ext cx="749808" cy="422969"/>
+          </a:xfrm>
+          <a:prstGeom prst="rect">
+            <a:avLst/>
+          </a:prstGeom>
+        </p:spPr>
+      </p:pic>
+      <p:sp>
+        <p:nvSpPr>
+          <p:cNvPr id="6" name="Rounded Rectangle 5"/>
           <p:cNvSpPr/>
           <p:nvPr/>
         </p:nvSpPr>
@@ -5243,7 +5339,7 @@
       </p:sp>
       <p:sp>
         <p:nvSpPr>
-          <p:cNvPr id="6" name="TextBox 5"/>
+          <p:cNvPr id="7" name="TextBox 6"/>
           <p:cNvSpPr txBox="1"/>
           <p:nvPr/>
         </p:nvSpPr>
@@ -5323,7 +5419,7 @@
       </p:sp>
       <p:sp>
         <p:nvSpPr>
-          <p:cNvPr id="7" name="Rounded Rectangle 6"/>
+          <p:cNvPr id="8" name="Rounded Rectangle 7"/>
           <p:cNvSpPr/>
           <p:nvPr/>
         </p:nvSpPr>
@@ -5368,7 +5464,7 @@
       </p:sp>
       <p:sp>
         <p:nvSpPr>
-          <p:cNvPr id="8" name="TextBox 7"/>
+          <p:cNvPr id="9" name="TextBox 8"/>
           <p:cNvSpPr txBox="1"/>
           <p:nvPr/>
         </p:nvSpPr>
@@ -5448,7 +5544,7 @@
       </p:sp>
       <p:sp>
         <p:nvSpPr>
-          <p:cNvPr id="9" name="Rounded Rectangle 8"/>
+          <p:cNvPr id="10" name="Rounded Rectangle 9"/>
           <p:cNvSpPr/>
           <p:nvPr/>
         </p:nvSpPr>
@@ -5493,7 +5589,7 @@
       </p:sp>
       <p:sp>
         <p:nvSpPr>
-          <p:cNvPr id="10" name="TextBox 9"/>
+          <p:cNvPr id="11" name="TextBox 10"/>
           <p:cNvSpPr txBox="1"/>
           <p:nvPr/>
         </p:nvSpPr>
@@ -5573,7 +5669,7 @@
       </p:sp>
       <p:sp>
         <p:nvSpPr>
-          <p:cNvPr id="11" name="Rounded Rectangle 10"/>
+          <p:cNvPr id="12" name="Rounded Rectangle 11"/>
           <p:cNvSpPr/>
           <p:nvPr/>
         </p:nvSpPr>
@@ -5618,7 +5714,7 @@
       </p:sp>
       <p:sp>
         <p:nvSpPr>
-          <p:cNvPr id="12" name="TextBox 11"/>
+          <p:cNvPr id="13" name="TextBox 12"/>
           <p:cNvSpPr txBox="1"/>
           <p:nvPr/>
         </p:nvSpPr>
@@ -5800,8 +5896,8 @@
         </p:nvSpPr>
         <p:spPr>
           <a:xfrm>
-            <a:off x="10515600" y="457200"/>
-            <a:ext cx="914400" cy="320040"/>
+            <a:off x="9509760" y="457200"/>
+            <a:ext cx="1005840" cy="320040"/>
           </a:xfrm>
           <a:prstGeom prst="rect">
             <a:avLst/>
@@ -5827,9 +5923,33 @@
           </a:p>
         </p:txBody>
       </p:sp>
-      <p:sp>
-        <p:nvSpPr>
-          <p:cNvPr id="5" name="Rounded Rectangle 4"/>
+      <p:pic>
+        <p:nvPicPr>
+          <p:cNvPr id="5" name="Picture 4" descr="nxtwave_white_logo.png"/>
+          <p:cNvPicPr>
+            <a:picLocks noChangeAspect="1"/>
+          </p:cNvPicPr>
+          <p:nvPr/>
+        </p:nvPicPr>
+        <p:blipFill>
+          <a:blip r:embed="rId2"/>
+          <a:stretch>
+            <a:fillRect/>
+          </a:stretch>
+        </p:blipFill>
+        <p:spPr>
+          <a:xfrm>
+            <a:off x="10744200" y="384048"/>
+            <a:ext cx="749808" cy="422969"/>
+          </a:xfrm>
+          <a:prstGeom prst="rect">
+            <a:avLst/>
+          </a:prstGeom>
+        </p:spPr>
+      </p:pic>
+      <p:sp>
+        <p:nvSpPr>
+          <p:cNvPr id="6" name="Rounded Rectangle 5"/>
           <p:cNvSpPr/>
           <p:nvPr/>
         </p:nvSpPr>
@@ -5874,7 +5994,7 @@
       </p:sp>
       <p:sp>
         <p:nvSpPr>
-          <p:cNvPr id="6" name="TextBox 5"/>
+          <p:cNvPr id="7" name="TextBox 6"/>
           <p:cNvSpPr txBox="1"/>
           <p:nvPr/>
         </p:nvSpPr>
@@ -6080,7 +6200,7 @@
       </p:sp>
       <p:sp>
         <p:nvSpPr>
-          <p:cNvPr id="7" name="Rounded Rectangle 6"/>
+          <p:cNvPr id="8" name="Rounded Rectangle 7"/>
           <p:cNvSpPr/>
           <p:nvPr/>
         </p:nvSpPr>
@@ -6125,7 +6245,7 @@
       </p:sp>
       <p:sp>
         <p:nvSpPr>
-          <p:cNvPr id="8" name="TextBox 7"/>
+          <p:cNvPr id="9" name="TextBox 8"/>
           <p:cNvSpPr txBox="1"/>
           <p:nvPr/>
         </p:nvSpPr>

</xml_diff>